<commit_message>
Updated for forgot pass
</commit_message>
<xml_diff>
--- a/Content (2).pptx
+++ b/Content (2).pptx
@@ -354,7 +354,7 @@
             <a:fld id="{1D8BD707-D9CF-40AE-B4C6-C98DA3205C09}" type="datetimeFigureOut">
               <a:rPr lang="en-US" smtClean="0"/>
               <a:pPr/>
-              <a:t>4/29/2026</a:t>
+              <a:t>4/30/2026</a:t>
             </a:fld>
             <a:endParaRPr lang="en-US"/>
           </a:p>
@@ -519,7 +519,7 @@
             <a:fld id="{1D8BD707-D9CF-40AE-B4C6-C98DA3205C09}" type="datetimeFigureOut">
               <a:rPr lang="en-US" smtClean="0"/>
               <a:pPr/>
-              <a:t>4/29/2026</a:t>
+              <a:t>4/30/2026</a:t>
             </a:fld>
             <a:endParaRPr lang="en-US"/>
           </a:p>
@@ -694,7 +694,7 @@
             <a:fld id="{1D8BD707-D9CF-40AE-B4C6-C98DA3205C09}" type="datetimeFigureOut">
               <a:rPr lang="en-US" smtClean="0"/>
               <a:pPr/>
-              <a:t>4/29/2026</a:t>
+              <a:t>4/30/2026</a:t>
             </a:fld>
             <a:endParaRPr lang="en-US"/>
           </a:p>
@@ -859,7 +859,7 @@
             <a:fld id="{1D8BD707-D9CF-40AE-B4C6-C98DA3205C09}" type="datetimeFigureOut">
               <a:rPr lang="en-US" smtClean="0"/>
               <a:pPr/>
-              <a:t>4/29/2026</a:t>
+              <a:t>4/30/2026</a:t>
             </a:fld>
             <a:endParaRPr lang="en-US"/>
           </a:p>
@@ -1101,7 +1101,7 @@
             <a:fld id="{1D8BD707-D9CF-40AE-B4C6-C98DA3205C09}" type="datetimeFigureOut">
               <a:rPr lang="en-US" smtClean="0"/>
               <a:pPr/>
-              <a:t>4/29/2026</a:t>
+              <a:t>4/30/2026</a:t>
             </a:fld>
             <a:endParaRPr lang="en-US"/>
           </a:p>
@@ -1383,7 +1383,7 @@
             <a:fld id="{1D8BD707-D9CF-40AE-B4C6-C98DA3205C09}" type="datetimeFigureOut">
               <a:rPr lang="en-US" smtClean="0"/>
               <a:pPr/>
-              <a:t>4/29/2026</a:t>
+              <a:t>4/30/2026</a:t>
             </a:fld>
             <a:endParaRPr lang="en-US"/>
           </a:p>
@@ -1799,7 +1799,7 @@
             <a:fld id="{1D8BD707-D9CF-40AE-B4C6-C98DA3205C09}" type="datetimeFigureOut">
               <a:rPr lang="en-US" smtClean="0"/>
               <a:pPr/>
-              <a:t>4/29/2026</a:t>
+              <a:t>4/30/2026</a:t>
             </a:fld>
             <a:endParaRPr lang="en-US"/>
           </a:p>
@@ -1913,7 +1913,7 @@
             <a:fld id="{1D8BD707-D9CF-40AE-B4C6-C98DA3205C09}" type="datetimeFigureOut">
               <a:rPr lang="en-US" smtClean="0"/>
               <a:pPr/>
-              <a:t>4/29/2026</a:t>
+              <a:t>4/30/2026</a:t>
             </a:fld>
             <a:endParaRPr lang="en-US"/>
           </a:p>
@@ -2005,7 +2005,7 @@
             <a:fld id="{1D8BD707-D9CF-40AE-B4C6-C98DA3205C09}" type="datetimeFigureOut">
               <a:rPr lang="en-US" smtClean="0"/>
               <a:pPr/>
-              <a:t>4/29/2026</a:t>
+              <a:t>4/30/2026</a:t>
             </a:fld>
             <a:endParaRPr lang="en-US"/>
           </a:p>
@@ -2277,7 +2277,7 @@
             <a:fld id="{1D8BD707-D9CF-40AE-B4C6-C98DA3205C09}" type="datetimeFigureOut">
               <a:rPr lang="en-US" smtClean="0"/>
               <a:pPr/>
-              <a:t>4/29/2026</a:t>
+              <a:t>4/30/2026</a:t>
             </a:fld>
             <a:endParaRPr lang="en-US"/>
           </a:p>
@@ -2526,7 +2526,7 @@
             <a:fld id="{1D8BD707-D9CF-40AE-B4C6-C98DA3205C09}" type="datetimeFigureOut">
               <a:rPr lang="en-US" smtClean="0"/>
               <a:pPr/>
-              <a:t>4/29/2026</a:t>
+              <a:t>4/30/2026</a:t>
             </a:fld>
             <a:endParaRPr lang="en-US"/>
           </a:p>
@@ -2734,7 +2734,7 @@
             <a:fld id="{1D8BD707-D9CF-40AE-B4C6-C98DA3205C09}" type="datetimeFigureOut">
               <a:rPr lang="en-US" smtClean="0"/>
               <a:pPr/>
-              <a:t>4/29/2026</a:t>
+              <a:t>4/30/2026</a:t>
             </a:fld>
             <a:endParaRPr lang="en-US"/>
           </a:p>
@@ -8849,14 +8849,14 @@
         <p:spPr>
           <a:xfrm>
             <a:off x="451128" y="679270"/>
-            <a:ext cx="10983159" cy="1543048"/>
+            <a:ext cx="12883872" cy="1543048"/>
           </a:xfrm>
           <a:prstGeom prst="rect">
             <a:avLst/>
           </a:prstGeom>
         </p:spPr>
         <p:txBody>
-          <a:bodyPr lIns="0" tIns="0" rIns="0" bIns="0" rtlCol="0" anchor="t">
+          <a:bodyPr wrap="square" lIns="0" tIns="0" rIns="0" bIns="0" rtlCol="0" anchor="t">
             <a:spAutoFit/>
           </a:bodyPr>
           <a:lstStyle/>
@@ -8867,7 +8867,7 @@
               </a:lnSpc>
             </a:pPr>
             <a:r>
-              <a:rPr lang="en-US" sz="9000">
+              <a:rPr lang="en-US" sz="9000" dirty="0">
                 <a:solidFill>
                   <a:srgbClr val="000000"/>
                 </a:solidFill>

</xml_diff>